<commit_message>
CNN classification grid + regression on augmented sim; Deck 5 result slides
- CNN classification grid (actual model, LOSO): sim 98% full, degrades to 33%
  at 1-ant 100MHz; measured empty robust, F4 1-ant breaks (48%), F5 hard for the
  CNN (72% full, 1-ant 34%). Runs a bit below the k-NN floor on small-data F5.
- Regression on noise-injected sim (LOSO): 16S full 7.0mm; reflection-only BEATS
  all-16 (4.6mm) - low-SNR transmission channels add more noise than signal once
  realistic noise is present; 1-ant breaks at narrow bands.
- Deck 5: result slide now the CNN classification grid + a new regression slide.

Co-Authored-By: Claude Opus 4.8 <noreply@anthropic.com>
</commit_message>
<xml_diff>
--- a/regression_deck/Deck5_Sim_Augmentation.pptx
+++ b/regression_deck/Deck5_Sim_Augmentation.pptx
@@ -12,9 +12,10 @@
     <p:sldId id="260" r:id="rId6"/>
     <p:sldId id="261" r:id="rId7"/>
     <p:sldId id="262" r:id="rId8"/>
+    <p:sldId id="263" r:id="rId9"/>
   </p:sldIdLst>
   <p:notesMasterIdLst>
-    <p:notesMasterId r:id="rId9"/>
+    <p:notesMasterId r:id="rId10"/>
   </p:notesMasterIdLst>
   <p:sldSz cx="12188952" cy="6858000"/>
   <p:notesSz cx="6858000" cy="12188952"/>
@@ -1060,6 +1061,94 @@
             <a:fld id="{F7021451-1387-4CA6-816F-3879F97B5CBC}" type="slidenum">
               <a:rPr lang="en-US"/>
               <a:t>7</a:t>
+            </a:fld>
+            <a:endParaRPr lang="en-US"/>
+          </a:p>
+        </p:txBody>
+      </p:sp>
+    </p:spTree>
+    <p:extLst>
+      <p:ext uri="{BB962C8B-B14F-4D97-AF65-F5344CB8AC3E}">
+        <p14:creationId xmlns:p14="http://schemas.microsoft.com/office/powerpoint/2010/main" val="1024086991"/>
+      </p:ext>
+    </p:extLst>
+  </p:cSld>
+  <p:clrMapOvr>
+    <a:masterClrMapping/>
+  </p:clrMapOvr>
+</p:notes>
+</file>
+
+<file path=ppt/notesSlides/notesSlide8.xml><?xml version="1.0" encoding="utf-8"?>
+<p:notes xmlns:a="http://schemas.openxmlformats.org/drawingml/2006/main" xmlns:r="http://schemas.openxmlformats.org/officeDocument/2006/relationships" xmlns:p="http://schemas.openxmlformats.org/presentationml/2006/main">
+  <p:cSld>
+    <p:spTree>
+      <p:nvGrpSpPr>
+        <p:cNvPr id="1" name=""/>
+        <p:cNvGrpSpPr/>
+        <p:nvPr/>
+      </p:nvGrpSpPr>
+      <p:grpSpPr>
+        <a:xfrm>
+          <a:off x="0" y="0"/>
+          <a:ext cx="0" cy="0"/>
+          <a:chOff x="0" y="0"/>
+          <a:chExt cx="0" cy="0"/>
+        </a:xfrm>
+      </p:grpSpPr>
+      <p:sp>
+        <p:nvSpPr>
+          <p:cNvPr id="2" name="Slide Image Placeholder 1"/>
+          <p:cNvSpPr>
+            <a:spLocks noGrp="1" noRot="1" noChangeAspect="1"/>
+          </p:cNvSpPr>
+          <p:nvPr>
+            <p:ph type="sldImg"/>
+          </p:nvPr>
+        </p:nvSpPr>
+        <p:spPr/>
+      </p:sp>
+      <p:sp>
+        <p:nvSpPr>
+          <p:cNvPr id="3" name="Notes Placeholder 2"/>
+          <p:cNvSpPr>
+            <a:spLocks noGrp="1"/>
+          </p:cNvSpPr>
+          <p:nvPr>
+            <p:ph type="body" idx="1"/>
+          </p:nvPr>
+        </p:nvSpPr>
+        <p:spPr/>
+        <p:txBody>
+          <a:bodyPr/>
+          <a:lstStyle/>
+          <a:p>
+            <a:r>
+              <a:rPr lang="en-US" dirty="0"/>
+              <a:t/>
+            </a:r>
+            <a:endParaRPr lang="en-US" dirty="0"/>
+          </a:p>
+        </p:txBody>
+      </p:sp>
+      <p:sp>
+        <p:nvSpPr>
+          <p:cNvPr id="4" name="Slide Number Placeholder 3"/>
+          <p:cNvSpPr>
+            <a:spLocks noGrp="1"/>
+          </p:cNvSpPr>
+          <p:nvPr>
+            <p:ph type="sldNum" sz="quarter" idx="10"/>
+          </p:nvPr>
+        </p:nvSpPr>
+        <p:spPr/>
+        <p:txBody>
+          <a:bodyPr/>
+          <a:lstStyle/>
+          <a:p>
+            <a:fld id="{F7021451-1387-4CA6-816F-3879F97B5CBC}" type="slidenum">
+              <a:rPr lang="en-US"/>
+              <a:t>8</a:t>
             </a:fld>
             <a:endParaRPr lang="en-US"/>
           </a:p>
@@ -4712,7 +4801,7 @@
                 <a:ea typeface="Cambria" pitchFamily="34" charset="-122"/>
                 <a:cs typeface="Cambria" pitchFamily="34" charset="-120"/>
               </a:rPr>
-              <a:t>Result: the augmented sim supports LOSO / classification</a:t>
+              <a:t>Result: classification CNN on the augmented sim (LOSO)</a:t>
             </a:r>
             <a:endParaRPr lang="en-US" sz="2500" dirty="0"/>
           </a:p>
@@ -4751,7 +4840,7 @@
                 <a:ea typeface="Calibri" pitchFamily="34" charset="-122"/>
                 <a:cs typeface="Calibri" pitchFamily="34" charset="-120"/>
               </a:rPr>
-              <a:t>Same k-NN LOSO classifier on augmented sim + measured phantoms (CNN full-config anchor: sim 99.5%)</a:t>
+              <a:t>Actual CNN classifier on augmented sim + measured phantoms; hardware x band reduction (black box = &lt;50%)</a:t>
             </a:r>
             <a:endParaRPr lang="en-US" sz="1350" dirty="0"/>
           </a:p>
@@ -4759,7 +4848,7 @@
       </p:sp>
       <p:pic>
         <p:nvPicPr>
-          <p:cNvPr id="5" name="Image 0" descr="classify_grid.png">    </p:cNvPr>
+          <p:cNvPr id="5" name="Image 0" descr="classify_grid_cnn.png">    </p:cNvPr>
           <p:cNvPicPr>
             <a:picLocks noChangeAspect="1"/>
           </p:cNvPicPr>
@@ -4775,6 +4864,160 @@
           <a:xfrm>
             <a:off x="2088533" y="1371600"/>
             <a:ext cx="8011886" cy="5257800"/>
+          </a:xfrm>
+          <a:prstGeom prst="rect">
+            <a:avLst/>
+          </a:prstGeom>
+        </p:spPr>
+      </p:pic>
+    </p:spTree>
+  </p:cSld>
+  <p:clrMapOvr>
+    <a:masterClrMapping/>
+  </p:clrMapOvr>
+</p:sld>
+</file>
+
+<file path=ppt/slides/slide8.xml><?xml version="1.0" encoding="utf-8"?>
+<p:sld xmlns:a="http://schemas.openxmlformats.org/drawingml/2006/main" xmlns:r="http://schemas.openxmlformats.org/officeDocument/2006/relationships" xmlns:p="http://schemas.openxmlformats.org/presentationml/2006/main">
+  <p:cSld name="Slide 8">
+    <p:bg>
+      <p:bgPr>
+        <a:solidFill>
+          <a:srgbClr val="FFFFFF"/>
+        </a:solidFill>
+      </p:bgPr>
+    </p:bg>
+    <p:spTree>
+      <p:nvGrpSpPr>
+        <p:cNvPr id="1" name=""/>
+        <p:cNvGrpSpPr/>
+        <p:nvPr/>
+      </p:nvGrpSpPr>
+      <p:grpSpPr>
+        <a:xfrm>
+          <a:off x="0" y="0"/>
+          <a:ext cx="0" cy="0"/>
+          <a:chOff x="0" y="0"/>
+          <a:chExt cx="0" cy="0"/>
+        </a:xfrm>
+      </p:grpSpPr>
+      <p:sp>
+        <p:nvSpPr>
+          <p:cNvPr id="2" name="Shape 0"/>
+          <p:cNvSpPr/>
+          <p:nvPr/>
+        </p:nvSpPr>
+        <p:spPr>
+          <a:xfrm>
+            <a:off x="0" y="0"/>
+            <a:ext cx="12188952" cy="109728"/>
+          </a:xfrm>
+          <a:prstGeom prst="rect">
+            <a:avLst/>
+          </a:prstGeom>
+          <a:solidFill>
+            <a:srgbClr val="BE0000"/>
+          </a:solidFill>
+          <a:ln/>
+        </p:spPr>
+      </p:sp>
+      <p:sp>
+        <p:nvSpPr>
+          <p:cNvPr id="3" name="Text 1"/>
+          <p:cNvSpPr/>
+          <p:nvPr/>
+        </p:nvSpPr>
+        <p:spPr>
+          <a:xfrm>
+            <a:off x="502920" y="292608"/>
+            <a:ext cx="11183112" cy="566928"/>
+          </a:xfrm>
+          <a:prstGeom prst="rect">
+            <a:avLst/>
+          </a:prstGeom>
+          <a:noFill/>
+          <a:ln/>
+        </p:spPr>
+        <p:txBody>
+          <a:bodyPr wrap="square" lIns="0" tIns="0" rIns="0" bIns="0" rtlCol="0" anchor="ctr"/>
+          <a:lstStyle/>
+          <a:p>
+            <a:pPr indent="0" marL="0">
+              <a:buNone/>
+            </a:pPr>
+            <a:r>
+              <a:rPr lang="en-US" sz="2500" b="1" dirty="0">
+                <a:solidFill>
+                  <a:srgbClr val="2A1618"/>
+                </a:solidFill>
+                <a:latin typeface="Cambria" pitchFamily="34" charset="0"/>
+                <a:ea typeface="Cambria" pitchFamily="34" charset="-122"/>
+                <a:cs typeface="Cambria" pitchFamily="34" charset="-120"/>
+              </a:rPr>
+              <a:t>Regression (x,y) on the augmented sim (LOSO)</a:t>
+            </a:r>
+            <a:endParaRPr lang="en-US" sz="2500" dirty="0"/>
+          </a:p>
+        </p:txBody>
+      </p:sp>
+      <p:sp>
+        <p:nvSpPr>
+          <p:cNvPr id="4" name="Text 2"/>
+          <p:cNvSpPr/>
+          <p:nvPr/>
+        </p:nvSpPr>
+        <p:spPr>
+          <a:xfrm>
+            <a:off x="502920" y="896112"/>
+            <a:ext cx="11183112" cy="365760"/>
+          </a:xfrm>
+          <a:prstGeom prst="rect">
+            <a:avLst/>
+          </a:prstGeom>
+          <a:noFill/>
+          <a:ln/>
+        </p:spPr>
+        <p:txBody>
+          <a:bodyPr wrap="square" lIns="0" tIns="0" rIns="0" bIns="0" rtlCol="0" anchor="ctr"/>
+          <a:lstStyle/>
+          <a:p>
+            <a:pPr indent="0" marL="0">
+              <a:buNone/>
+            </a:pPr>
+            <a:r>
+              <a:rPr lang="en-US" sz="1350" b="1" dirty="0">
+                <a:solidFill>
+                  <a:srgbClr val="BE0000"/>
+                </a:solidFill>
+                <a:latin typeface="Calibri" pitchFamily="34" charset="0"/>
+                <a:ea typeface="Calibri" pitchFamily="34" charset="-122"/>
+                <a:cs typeface="Calibri" pitchFamily="34" charset="-120"/>
+              </a:rPr>
+              <a:t>Median lateral error under hardware x band reduction; reflection-only beats all-16 once realistic noise is present</a:t>
+            </a:r>
+            <a:endParaRPr lang="en-US" sz="1350" dirty="0"/>
+          </a:p>
+        </p:txBody>
+      </p:sp>
+      <p:pic>
+        <p:nvPicPr>
+          <p:cNvPr id="5" name="Image 0" descr="sim_reg_noisy_grid.png">    </p:cNvPr>
+          <p:cNvPicPr>
+            <a:picLocks noChangeAspect="1"/>
+          </p:cNvPicPr>
+          <p:nvPr/>
+        </p:nvPicPr>
+        <p:blipFill>
+          <a:blip r:embed="rId1"/>
+          <a:stretch>
+            <a:fillRect/>
+          </a:stretch>
+        </p:blipFill>
+        <p:spPr>
+          <a:xfrm>
+            <a:off x="1416968" y="1417320"/>
+            <a:ext cx="9355015" cy="5120640"/>
           </a:xfrm>
           <a:prstGeom prst="rect">
             <a:avLst/>

</xml_diff>

<commit_message>
Rebuild Deck5 pptx with matched classification figure (prior commit had stale pptx, file was locked by PowerPoint)
Co-Authored-By: Claude Opus 4.8 <noreply@anthropic.com>
</commit_message>
<xml_diff>
--- a/regression_deck/Deck5_Sim_Augmentation.pptx
+++ b/regression_deck/Deck5_Sim_Augmentation.pptx
@@ -4801,7 +4801,7 @@
                 <a:ea typeface="Cambria" pitchFamily="34" charset="-122"/>
                 <a:cs typeface="Cambria" pitchFamily="34" charset="-120"/>
               </a:rPr>
-              <a:t>Result: classification CNN on the augmented sim (LOSO)</a:t>
+              <a:t>Result: classification under reduction (LOSO)</a:t>
             </a:r>
             <a:endParaRPr lang="en-US" sz="2500" dirty="0"/>
           </a:p>
@@ -4840,7 +4840,7 @@
                 <a:ea typeface="Calibri" pitchFamily="34" charset="-122"/>
                 <a:cs typeface="Calibri" pitchFamily="34" charset="-120"/>
               </a:rPr>
-              <a:t>Actual CNN classifier on augmented sim + measured phantoms; hardware x band reduction (black box = &lt;50%)</a:t>
+              <a:t>Measured (Empty/F4/F5) = the classification-CNN track (cnn_loso, per-position vote); Sim = augmented. Black box = &lt;50%.</a:t>
             </a:r>
             <a:endParaRPr lang="en-US" sz="1350" dirty="0"/>
           </a:p>
@@ -4848,7 +4848,7 @@
       </p:sp>
       <p:pic>
         <p:nvPicPr>
-          <p:cNvPr id="5" name="Image 0" descr="classify_grid_cnn.png">    </p:cNvPr>
+          <p:cNvPr id="5" name="Image 0" descr="classify_grid_matched.png">    </p:cNvPr>
           <p:cNvPicPr>
             <a:picLocks noChangeAspect="1"/>
           </p:cNvPicPr>

</xml_diff>